<commit_message>
Regenerate PDF report and slide deck from computed figures
- src/report_metrics.py computes every quoted figure from data/ and metrics/
- build_detailed_report.py and build_professional_slides.py now read from it,
  replacing hard-coded numbers that did not match the data (e.g. 25.8% -> 23.1%
  month-1 retention, 62.4% -> 84.7% core revenue share)
- Unverifiable claims removed (projected CAC/margin impact, fixed day windows,
  invented targets); Tableau tracking items now point to the Power BI dashboard
- Holiday-cohort finding recomputed (Nov 2010 17.5%, Dec 2010 9.2%)
- Removed generate_presentation_and_pdf.py, an older duplicate generator

Co-Authored-By: Claude Opus 5.5 (1M context) <noreply@anthropic.com>
Claude-Session: https://claude.ai/code/session_01XCXU3sEodtB3eTNnz92XEh
</commit_message>
<xml_diff>
--- a/presentations/Executive_Presentation_Customer_Segmentation_Cohort.pptx
+++ b/presentations/Executive_Presentation_Customer_Segmentation_Cohort.pptx
@@ -5,15 +5,15 @@
     <p:sldMasterId id="2147483648" r:id="rId1"/>
   </p:sldMasterIdLst>
   <p:sldIdLst>
-    <p:sldId id="256" r:id="rId2"/>
-    <p:sldId id="257" r:id="rId3"/>
-    <p:sldId id="258" r:id="rId4"/>
-    <p:sldId id="259" r:id="rId5"/>
-    <p:sldId id="260" r:id="rId6"/>
-    <p:sldId id="261" r:id="rId7"/>
-    <p:sldId id="262" r:id="rId8"/>
+    <p:sldId id="256" r:id="rId7"/>
+    <p:sldId id="257" r:id="rId8"/>
+    <p:sldId id="258" r:id="rId9"/>
+    <p:sldId id="259" r:id="rId10"/>
+    <p:sldId id="260" r:id="rId11"/>
+    <p:sldId id="261" r:id="rId12"/>
+    <p:sldId id="262" r:id="rId13"/>
   </p:sldIdLst>
-  <p:sldSz cx="12192000" cy="6858000"/>
+  <p:sldSz cx="12191695" cy="6858000" type="screen4x3"/>
   <p:notesSz cx="6858000" cy="9144000"/>
   <p:defaultTextStyle>
     <a:defPPr>
@@ -110,22 +110,6 @@
       </a:defRPr>
     </a:lvl9pPr>
   </p:defaultTextStyle>
-  <p:extLst>
-    <p:ext uri="{EFAFB233-063F-42B5-8137-9DF3F51BA10A}">
-      <p15:sldGuideLst xmlns:p15="http://schemas.microsoft.com/office/powerpoint/2012/main">
-        <p15:guide id="1" orient="horz" pos="2160">
-          <p15:clr>
-            <a:srgbClr val="A4A3A4"/>
-          </p15:clr>
-        </p15:guide>
-        <p15:guide id="2" pos="2880">
-          <p15:clr>
-            <a:srgbClr val="A4A3A4"/>
-          </p15:clr>
-        </p15:guide>
-      </p15:sldGuideLst>
-    </p:ext>
-  </p:extLst>
 </p:presentation>
 </file>
 
@@ -167,9 +151,10 @@
           <a:lstStyle/>
           <a:p>
             <a:r>
-              <a:rPr lang="en-US"/>
+              <a:rPr lang="en-US" smtClean="0"/>
               <a:t>Click to edit Master title style</a:t>
             </a:r>
+            <a:endParaRPr lang="en-US"/>
           </a:p>
         </p:txBody>
       </p:sp>
@@ -285,9 +270,10 @@
           </a:lstStyle>
           <a:p>
             <a:r>
-              <a:rPr lang="en-US"/>
+              <a:rPr lang="en-US" smtClean="0"/>
               <a:t>Click to edit Master subtitle style</a:t>
             </a:r>
+            <a:endParaRPr lang="en-US"/>
           </a:p>
         </p:txBody>
       </p:sp>
@@ -308,7 +294,7 @@
           <a:p>
             <a:fld id="{5BCAD085-E8A6-8845-BD4E-CB4CCA059FC4}" type="datetimeFigureOut">
               <a:rPr lang="en-US" smtClean="0"/>
-              <a:t>9/19/26</a:t>
+              <a:t>1/27/13</a:t>
             </a:fld>
             <a:endParaRPr lang="en-US"/>
           </a:p>
@@ -402,9 +388,10 @@
           <a:lstStyle/>
           <a:p>
             <a:r>
-              <a:rPr lang="en-US"/>
+              <a:rPr lang="en-US" smtClean="0"/>
               <a:t>Click to edit Master title style</a:t>
             </a:r>
+            <a:endParaRPr lang="en-US"/>
           </a:p>
         </p:txBody>
       </p:sp>
@@ -425,37 +412,38 @@
           <a:p>
             <a:pPr lvl="0"/>
             <a:r>
-              <a:rPr lang="en-US"/>
+              <a:rPr lang="en-US" smtClean="0"/>
               <a:t>Click to edit Master text styles</a:t>
             </a:r>
           </a:p>
           <a:p>
             <a:pPr lvl="1"/>
             <a:r>
-              <a:rPr lang="en-US"/>
+              <a:rPr lang="en-US" smtClean="0"/>
               <a:t>Second level</a:t>
             </a:r>
           </a:p>
           <a:p>
             <a:pPr lvl="2"/>
             <a:r>
-              <a:rPr lang="en-US"/>
+              <a:rPr lang="en-US" smtClean="0"/>
               <a:t>Third level</a:t>
             </a:r>
           </a:p>
           <a:p>
             <a:pPr lvl="3"/>
             <a:r>
-              <a:rPr lang="en-US"/>
+              <a:rPr lang="en-US" smtClean="0"/>
               <a:t>Fourth level</a:t>
             </a:r>
           </a:p>
           <a:p>
             <a:pPr lvl="4"/>
             <a:r>
-              <a:rPr lang="en-US"/>
+              <a:rPr lang="en-US" smtClean="0"/>
               <a:t>Fifth level</a:t>
             </a:r>
+            <a:endParaRPr lang="en-US"/>
           </a:p>
         </p:txBody>
       </p:sp>
@@ -476,7 +464,7 @@
           <a:p>
             <a:fld id="{5BCAD085-E8A6-8845-BD4E-CB4CCA059FC4}" type="datetimeFigureOut">
               <a:rPr lang="en-US" smtClean="0"/>
-              <a:t>9/19/26</a:t>
+              <a:t>1/27/13</a:t>
             </a:fld>
             <a:endParaRPr lang="en-US"/>
           </a:p>
@@ -575,9 +563,10 @@
           <a:lstStyle/>
           <a:p>
             <a:r>
-              <a:rPr lang="en-US"/>
+              <a:rPr lang="en-US" smtClean="0"/>
               <a:t>Click to edit Master title style</a:t>
             </a:r>
+            <a:endParaRPr lang="en-US"/>
           </a:p>
         </p:txBody>
       </p:sp>
@@ -603,37 +592,38 @@
           <a:p>
             <a:pPr lvl="0"/>
             <a:r>
-              <a:rPr lang="en-US"/>
+              <a:rPr lang="en-US" smtClean="0"/>
               <a:t>Click to edit Master text styles</a:t>
             </a:r>
           </a:p>
           <a:p>
             <a:pPr lvl="1"/>
             <a:r>
-              <a:rPr lang="en-US"/>
+              <a:rPr lang="en-US" smtClean="0"/>
               <a:t>Second level</a:t>
             </a:r>
           </a:p>
           <a:p>
             <a:pPr lvl="2"/>
             <a:r>
-              <a:rPr lang="en-US"/>
+              <a:rPr lang="en-US" smtClean="0"/>
               <a:t>Third level</a:t>
             </a:r>
           </a:p>
           <a:p>
             <a:pPr lvl="3"/>
             <a:r>
-              <a:rPr lang="en-US"/>
+              <a:rPr lang="en-US" smtClean="0"/>
               <a:t>Fourth level</a:t>
             </a:r>
           </a:p>
           <a:p>
             <a:pPr lvl="4"/>
             <a:r>
-              <a:rPr lang="en-US"/>
+              <a:rPr lang="en-US" smtClean="0"/>
               <a:t>Fifth level</a:t>
             </a:r>
+            <a:endParaRPr lang="en-US"/>
           </a:p>
         </p:txBody>
       </p:sp>
@@ -654,7 +644,7 @@
           <a:p>
             <a:fld id="{5BCAD085-E8A6-8845-BD4E-CB4CCA059FC4}" type="datetimeFigureOut">
               <a:rPr lang="en-US" smtClean="0"/>
-              <a:t>9/19/26</a:t>
+              <a:t>1/27/13</a:t>
             </a:fld>
             <a:endParaRPr lang="en-US"/>
           </a:p>
@@ -748,9 +738,10 @@
           <a:lstStyle/>
           <a:p>
             <a:r>
-              <a:rPr lang="en-US"/>
+              <a:rPr lang="en-US" smtClean="0"/>
               <a:t>Click to edit Master title style</a:t>
             </a:r>
+            <a:endParaRPr lang="en-US"/>
           </a:p>
         </p:txBody>
       </p:sp>
@@ -771,37 +762,38 @@
           <a:p>
             <a:pPr lvl="0"/>
             <a:r>
-              <a:rPr lang="en-US"/>
+              <a:rPr lang="en-US" smtClean="0"/>
               <a:t>Click to edit Master text styles</a:t>
             </a:r>
           </a:p>
           <a:p>
             <a:pPr lvl="1"/>
             <a:r>
-              <a:rPr lang="en-US"/>
+              <a:rPr lang="en-US" smtClean="0"/>
               <a:t>Second level</a:t>
             </a:r>
           </a:p>
           <a:p>
             <a:pPr lvl="2"/>
             <a:r>
-              <a:rPr lang="en-US"/>
+              <a:rPr lang="en-US" smtClean="0"/>
               <a:t>Third level</a:t>
             </a:r>
           </a:p>
           <a:p>
             <a:pPr lvl="3"/>
             <a:r>
-              <a:rPr lang="en-US"/>
+              <a:rPr lang="en-US" smtClean="0"/>
               <a:t>Fourth level</a:t>
             </a:r>
           </a:p>
           <a:p>
             <a:pPr lvl="4"/>
             <a:r>
-              <a:rPr lang="en-US"/>
+              <a:rPr lang="en-US" smtClean="0"/>
               <a:t>Fifth level</a:t>
             </a:r>
+            <a:endParaRPr lang="en-US"/>
           </a:p>
         </p:txBody>
       </p:sp>
@@ -822,7 +814,7 @@
           <a:p>
             <a:fld id="{5BCAD085-E8A6-8845-BD4E-CB4CCA059FC4}" type="datetimeFigureOut">
               <a:rPr lang="en-US" smtClean="0"/>
-              <a:t>9/19/26</a:t>
+              <a:t>1/27/13</a:t>
             </a:fld>
             <a:endParaRPr lang="en-US"/>
           </a:p>
@@ -925,9 +917,10 @@
           </a:lstStyle>
           <a:p>
             <a:r>
-              <a:rPr lang="en-US"/>
+              <a:rPr lang="en-US" smtClean="0"/>
               <a:t>Click to edit Master title style</a:t>
             </a:r>
+            <a:endParaRPr lang="en-US"/>
           </a:p>
         </p:txBody>
       </p:sp>
@@ -1044,7 +1037,7 @@
           <a:p>
             <a:pPr lvl="0"/>
             <a:r>
-              <a:rPr lang="en-US"/>
+              <a:rPr lang="en-US" smtClean="0"/>
               <a:t>Click to edit Master text styles</a:t>
             </a:r>
           </a:p>
@@ -1067,7 +1060,7 @@
           <a:p>
             <a:fld id="{5BCAD085-E8A6-8845-BD4E-CB4CCA059FC4}" type="datetimeFigureOut">
               <a:rPr lang="en-US" smtClean="0"/>
-              <a:t>9/19/26</a:t>
+              <a:t>1/27/13</a:t>
             </a:fld>
             <a:endParaRPr lang="en-US"/>
           </a:p>
@@ -1161,9 +1154,10 @@
           <a:lstStyle/>
           <a:p>
             <a:r>
-              <a:rPr lang="en-US"/>
+              <a:rPr lang="en-US" smtClean="0"/>
               <a:t>Click to edit Master title style</a:t>
             </a:r>
+            <a:endParaRPr lang="en-US"/>
           </a:p>
         </p:txBody>
       </p:sp>
@@ -1217,37 +1211,38 @@
           <a:p>
             <a:pPr lvl="0"/>
             <a:r>
-              <a:rPr lang="en-US"/>
+              <a:rPr lang="en-US" smtClean="0"/>
               <a:t>Click to edit Master text styles</a:t>
             </a:r>
           </a:p>
           <a:p>
             <a:pPr lvl="1"/>
             <a:r>
-              <a:rPr lang="en-US"/>
+              <a:rPr lang="en-US" smtClean="0"/>
               <a:t>Second level</a:t>
             </a:r>
           </a:p>
           <a:p>
             <a:pPr lvl="2"/>
             <a:r>
-              <a:rPr lang="en-US"/>
+              <a:rPr lang="en-US" smtClean="0"/>
               <a:t>Third level</a:t>
             </a:r>
           </a:p>
           <a:p>
             <a:pPr lvl="3"/>
             <a:r>
-              <a:rPr lang="en-US"/>
+              <a:rPr lang="en-US" smtClean="0"/>
               <a:t>Fourth level</a:t>
             </a:r>
           </a:p>
           <a:p>
             <a:pPr lvl="4"/>
             <a:r>
-              <a:rPr lang="en-US"/>
+              <a:rPr lang="en-US" smtClean="0"/>
               <a:t>Fifth level</a:t>
             </a:r>
+            <a:endParaRPr lang="en-US"/>
           </a:p>
         </p:txBody>
       </p:sp>
@@ -1301,37 +1296,38 @@
           <a:p>
             <a:pPr lvl="0"/>
             <a:r>
-              <a:rPr lang="en-US"/>
+              <a:rPr lang="en-US" smtClean="0"/>
               <a:t>Click to edit Master text styles</a:t>
             </a:r>
           </a:p>
           <a:p>
             <a:pPr lvl="1"/>
             <a:r>
-              <a:rPr lang="en-US"/>
+              <a:rPr lang="en-US" smtClean="0"/>
               <a:t>Second level</a:t>
             </a:r>
           </a:p>
           <a:p>
             <a:pPr lvl="2"/>
             <a:r>
-              <a:rPr lang="en-US"/>
+              <a:rPr lang="en-US" smtClean="0"/>
               <a:t>Third level</a:t>
             </a:r>
           </a:p>
           <a:p>
             <a:pPr lvl="3"/>
             <a:r>
-              <a:rPr lang="en-US"/>
+              <a:rPr lang="en-US" smtClean="0"/>
               <a:t>Fourth level</a:t>
             </a:r>
           </a:p>
           <a:p>
             <a:pPr lvl="4"/>
             <a:r>
-              <a:rPr lang="en-US"/>
+              <a:rPr lang="en-US" smtClean="0"/>
               <a:t>Fifth level</a:t>
             </a:r>
+            <a:endParaRPr lang="en-US"/>
           </a:p>
         </p:txBody>
       </p:sp>
@@ -1352,7 +1348,7 @@
           <a:p>
             <a:fld id="{5BCAD085-E8A6-8845-BD4E-CB4CCA059FC4}" type="datetimeFigureOut">
               <a:rPr lang="en-US" smtClean="0"/>
-              <a:t>9/19/26</a:t>
+              <a:t>1/27/13</a:t>
             </a:fld>
             <a:endParaRPr lang="en-US"/>
           </a:p>
@@ -1450,9 +1446,10 @@
           </a:lstStyle>
           <a:p>
             <a:r>
-              <a:rPr lang="en-US"/>
+              <a:rPr lang="en-US" smtClean="0"/>
               <a:t>Click to edit Master title style</a:t>
             </a:r>
+            <a:endParaRPr lang="en-US"/>
           </a:p>
         </p:txBody>
       </p:sp>
@@ -1515,7 +1512,7 @@
           <a:p>
             <a:pPr lvl="0"/>
             <a:r>
-              <a:rPr lang="en-US"/>
+              <a:rPr lang="en-US" smtClean="0"/>
               <a:t>Click to edit Master text styles</a:t>
             </a:r>
           </a:p>
@@ -1571,37 +1568,38 @@
           <a:p>
             <a:pPr lvl="0"/>
             <a:r>
-              <a:rPr lang="en-US"/>
+              <a:rPr lang="en-US" smtClean="0"/>
               <a:t>Click to edit Master text styles</a:t>
             </a:r>
           </a:p>
           <a:p>
             <a:pPr lvl="1"/>
             <a:r>
-              <a:rPr lang="en-US"/>
+              <a:rPr lang="en-US" smtClean="0"/>
               <a:t>Second level</a:t>
             </a:r>
           </a:p>
           <a:p>
             <a:pPr lvl="2"/>
             <a:r>
-              <a:rPr lang="en-US"/>
+              <a:rPr lang="en-US" smtClean="0"/>
               <a:t>Third level</a:t>
             </a:r>
           </a:p>
           <a:p>
             <a:pPr lvl="3"/>
             <a:r>
-              <a:rPr lang="en-US"/>
+              <a:rPr lang="en-US" smtClean="0"/>
               <a:t>Fourth level</a:t>
             </a:r>
           </a:p>
           <a:p>
             <a:pPr lvl="4"/>
             <a:r>
-              <a:rPr lang="en-US"/>
+              <a:rPr lang="en-US" smtClean="0"/>
               <a:t>Fifth level</a:t>
             </a:r>
+            <a:endParaRPr lang="en-US"/>
           </a:p>
         </p:txBody>
       </p:sp>
@@ -1664,7 +1662,7 @@
           <a:p>
             <a:pPr lvl="0"/>
             <a:r>
-              <a:rPr lang="en-US"/>
+              <a:rPr lang="en-US" smtClean="0"/>
               <a:t>Click to edit Master text styles</a:t>
             </a:r>
           </a:p>
@@ -1720,37 +1718,38 @@
           <a:p>
             <a:pPr lvl="0"/>
             <a:r>
-              <a:rPr lang="en-US"/>
+              <a:rPr lang="en-US" smtClean="0"/>
               <a:t>Click to edit Master text styles</a:t>
             </a:r>
           </a:p>
           <a:p>
             <a:pPr lvl="1"/>
             <a:r>
-              <a:rPr lang="en-US"/>
+              <a:rPr lang="en-US" smtClean="0"/>
               <a:t>Second level</a:t>
             </a:r>
           </a:p>
           <a:p>
             <a:pPr lvl="2"/>
             <a:r>
-              <a:rPr lang="en-US"/>
+              <a:rPr lang="en-US" smtClean="0"/>
               <a:t>Third level</a:t>
             </a:r>
           </a:p>
           <a:p>
             <a:pPr lvl="3"/>
             <a:r>
-              <a:rPr lang="en-US"/>
+              <a:rPr lang="en-US" smtClean="0"/>
               <a:t>Fourth level</a:t>
             </a:r>
           </a:p>
           <a:p>
             <a:pPr lvl="4"/>
             <a:r>
-              <a:rPr lang="en-US"/>
+              <a:rPr lang="en-US" smtClean="0"/>
               <a:t>Fifth level</a:t>
             </a:r>
+            <a:endParaRPr lang="en-US"/>
           </a:p>
         </p:txBody>
       </p:sp>
@@ -1771,7 +1770,7 @@
           <a:p>
             <a:fld id="{5BCAD085-E8A6-8845-BD4E-CB4CCA059FC4}" type="datetimeFigureOut">
               <a:rPr lang="en-US" smtClean="0"/>
-              <a:t>9/19/26</a:t>
+              <a:t>1/27/13</a:t>
             </a:fld>
             <a:endParaRPr lang="en-US"/>
           </a:p>
@@ -1865,9 +1864,10 @@
           <a:lstStyle/>
           <a:p>
             <a:r>
-              <a:rPr lang="en-US"/>
+              <a:rPr lang="en-US" smtClean="0"/>
               <a:t>Click to edit Master title style</a:t>
             </a:r>
+            <a:endParaRPr lang="en-US"/>
           </a:p>
         </p:txBody>
       </p:sp>
@@ -1888,7 +1888,7 @@
           <a:p>
             <a:fld id="{5BCAD085-E8A6-8845-BD4E-CB4CCA059FC4}" type="datetimeFigureOut">
               <a:rPr lang="en-US" smtClean="0"/>
-              <a:t>9/19/26</a:t>
+              <a:t>1/27/13</a:t>
             </a:fld>
             <a:endParaRPr lang="en-US"/>
           </a:p>
@@ -1983,7 +1983,7 @@
           <a:p>
             <a:fld id="{5BCAD085-E8A6-8845-BD4E-CB4CCA059FC4}" type="datetimeFigureOut">
               <a:rPr lang="en-US" smtClean="0"/>
-              <a:t>9/19/26</a:t>
+              <a:t>1/27/13</a:t>
             </a:fld>
             <a:endParaRPr lang="en-US"/>
           </a:p>
@@ -2086,9 +2086,10 @@
           </a:lstStyle>
           <a:p>
             <a:r>
-              <a:rPr lang="en-US"/>
+              <a:rPr lang="en-US" smtClean="0"/>
               <a:t>Click to edit Master title style</a:t>
             </a:r>
+            <a:endParaRPr lang="en-US"/>
           </a:p>
         </p:txBody>
       </p:sp>
@@ -2142,37 +2143,38 @@
           <a:p>
             <a:pPr lvl="0"/>
             <a:r>
-              <a:rPr lang="en-US"/>
+              <a:rPr lang="en-US" smtClean="0"/>
               <a:t>Click to edit Master text styles</a:t>
             </a:r>
           </a:p>
           <a:p>
             <a:pPr lvl="1"/>
             <a:r>
-              <a:rPr lang="en-US"/>
+              <a:rPr lang="en-US" smtClean="0"/>
               <a:t>Second level</a:t>
             </a:r>
           </a:p>
           <a:p>
             <a:pPr lvl="2"/>
             <a:r>
-              <a:rPr lang="en-US"/>
+              <a:rPr lang="en-US" smtClean="0"/>
               <a:t>Third level</a:t>
             </a:r>
           </a:p>
           <a:p>
             <a:pPr lvl="3"/>
             <a:r>
-              <a:rPr lang="en-US"/>
+              <a:rPr lang="en-US" smtClean="0"/>
               <a:t>Fourth level</a:t>
             </a:r>
           </a:p>
           <a:p>
             <a:pPr lvl="4"/>
             <a:r>
-              <a:rPr lang="en-US"/>
+              <a:rPr lang="en-US" smtClean="0"/>
               <a:t>Fifth level</a:t>
             </a:r>
+            <a:endParaRPr lang="en-US"/>
           </a:p>
         </p:txBody>
       </p:sp>
@@ -2235,7 +2237,7 @@
           <a:p>
             <a:pPr lvl="0"/>
             <a:r>
-              <a:rPr lang="en-US"/>
+              <a:rPr lang="en-US" smtClean="0"/>
               <a:t>Click to edit Master text styles</a:t>
             </a:r>
           </a:p>
@@ -2258,7 +2260,7 @@
           <a:p>
             <a:fld id="{5BCAD085-E8A6-8845-BD4E-CB4CCA059FC4}" type="datetimeFigureOut">
               <a:rPr lang="en-US" smtClean="0"/>
-              <a:t>9/19/26</a:t>
+              <a:t>1/27/13</a:t>
             </a:fld>
             <a:endParaRPr lang="en-US"/>
           </a:p>
@@ -2361,9 +2363,10 @@
           </a:lstStyle>
           <a:p>
             <a:r>
-              <a:rPr lang="en-US"/>
+              <a:rPr lang="en-US" smtClean="0"/>
               <a:t>Click to edit Master title style</a:t>
             </a:r>
+            <a:endParaRPr lang="en-US"/>
           </a:p>
         </p:txBody>
       </p:sp>
@@ -2487,7 +2490,7 @@
           <a:p>
             <a:pPr lvl="0"/>
             <a:r>
-              <a:rPr lang="en-US"/>
+              <a:rPr lang="en-US" smtClean="0"/>
               <a:t>Click to edit Master text styles</a:t>
             </a:r>
           </a:p>
@@ -2510,7 +2513,7 @@
           <a:p>
             <a:fld id="{5BCAD085-E8A6-8845-BD4E-CB4CCA059FC4}" type="datetimeFigureOut">
               <a:rPr lang="en-US" smtClean="0"/>
-              <a:t>9/19/26</a:t>
+              <a:t>1/27/13</a:t>
             </a:fld>
             <a:endParaRPr lang="en-US"/>
           </a:p>
@@ -2619,9 +2622,10 @@
           <a:lstStyle/>
           <a:p>
             <a:r>
-              <a:rPr lang="en-US"/>
+              <a:rPr lang="en-US" smtClean="0"/>
               <a:t>Click to edit Master title style</a:t>
             </a:r>
+            <a:endParaRPr lang="en-US"/>
           </a:p>
         </p:txBody>
       </p:sp>
@@ -2652,37 +2656,38 @@
           <a:p>
             <a:pPr lvl="0"/>
             <a:r>
-              <a:rPr lang="en-US"/>
+              <a:rPr lang="en-US" smtClean="0"/>
               <a:t>Click to edit Master text styles</a:t>
             </a:r>
           </a:p>
           <a:p>
             <a:pPr lvl="1"/>
             <a:r>
-              <a:rPr lang="en-US"/>
+              <a:rPr lang="en-US" smtClean="0"/>
               <a:t>Second level</a:t>
             </a:r>
           </a:p>
           <a:p>
             <a:pPr lvl="2"/>
             <a:r>
-              <a:rPr lang="en-US"/>
+              <a:rPr lang="en-US" smtClean="0"/>
               <a:t>Third level</a:t>
             </a:r>
           </a:p>
           <a:p>
             <a:pPr lvl="3"/>
             <a:r>
-              <a:rPr lang="en-US"/>
+              <a:rPr lang="en-US" smtClean="0"/>
               <a:t>Fourth level</a:t>
             </a:r>
           </a:p>
           <a:p>
             <a:pPr lvl="4"/>
             <a:r>
-              <a:rPr lang="en-US"/>
+              <a:rPr lang="en-US" smtClean="0"/>
               <a:t>Fifth level</a:t>
             </a:r>
+            <a:endParaRPr lang="en-US"/>
           </a:p>
         </p:txBody>
       </p:sp>
@@ -2721,7 +2726,7 @@
           <a:p>
             <a:fld id="{5BCAD085-E8A6-8845-BD4E-CB4CCA059FC4}" type="datetimeFigureOut">
               <a:rPr lang="en-US" smtClean="0"/>
-              <a:t>9/19/26</a:t>
+              <a:t>1/27/13</a:t>
             </a:fld>
             <a:endParaRPr lang="en-US"/>
           </a:p>
@@ -3080,7 +3085,7 @@
 </file>
 
 <file path=ppt/slides/slide1.xml><?xml version="1.0" encoding="utf-8"?>
-<p:sld xmlns:a="http://schemas.openxmlformats.org/drawingml/2006/main" xmlns:r="http://schemas.openxmlformats.org/officeDocument/2006/relationships" xmlns:p="http://schemas.openxmlformats.org/presentationml/2006/main">
+<p:sld xmlns:a="http://schemas.openxmlformats.org/drawingml/2006/main" xmlns:p="http://schemas.openxmlformats.org/presentationml/2006/main" xmlns:r="http://schemas.openxmlformats.org/officeDocument/2006/relationships">
   <p:cSld>
     <p:spTree>
       <p:nvGrpSpPr>
@@ -3088,14 +3093,7 @@
         <p:cNvGrpSpPr/>
         <p:nvPr/>
       </p:nvGrpSpPr>
-      <p:grpSpPr>
-        <a:xfrm>
-          <a:off x="0" y="0"/>
-          <a:ext cx="0" cy="0"/>
-          <a:chOff x="0" y="0"/>
-          <a:chExt cx="0" cy="0"/>
-        </a:xfrm>
-      </p:grpSpPr>
+      <p:grpSpPr/>
       <p:sp>
         <p:nvSpPr>
           <p:cNvPr id="2" name="Rectangle 1"/>
@@ -3136,7 +3134,6 @@
           <a:lstStyle/>
           <a:p>
             <a:pPr algn="ctr"/>
-            <a:endParaRPr/>
           </a:p>
         </p:txBody>
       </p:sp>
@@ -3182,7 +3179,6 @@
           <a:lstStyle/>
           <a:p>
             <a:pPr algn="ctr"/>
-            <a:endParaRPr/>
           </a:p>
         </p:txBody>
       </p:sp>
@@ -3203,7 +3199,7 @@
           <a:noFill/>
         </p:spPr>
         <p:txBody>
-          <a:bodyPr wrap="square" lIns="0" tIns="0" rIns="0" bIns="0">
+          <a:bodyPr wrap="square" lIns="0" rIns="0" tIns="0" bIns="0">
             <a:spAutoFit/>
           </a:bodyPr>
           <a:lstStyle/>
@@ -3304,7 +3300,7 @@
           </a:fontRef>
         </p:style>
         <p:txBody>
-          <a:bodyPr lIns="0" tIns="0" rIns="0" bIns="0" rtlCol="0" anchor="ctr"/>
+          <a:bodyPr rtlCol="0" anchor="ctr" lIns="0" rIns="0" tIns="0" bIns="0"/>
           <a:lstStyle/>
           <a:p>
             <a:pPr algn="ctr">
@@ -3370,7 +3366,7 @@
           </a:fontRef>
         </p:style>
         <p:txBody>
-          <a:bodyPr lIns="0" tIns="0" rIns="0" bIns="0" rtlCol="0" anchor="ctr"/>
+          <a:bodyPr rtlCol="0" anchor="ctr" lIns="0" rIns="0" tIns="0" bIns="0"/>
           <a:lstStyle/>
           <a:p>
             <a:pPr algn="ctr">
@@ -3436,7 +3432,7 @@
           </a:fontRef>
         </p:style>
         <p:txBody>
-          <a:bodyPr lIns="0" tIns="0" rIns="0" bIns="0" rtlCol="0" anchor="ctr"/>
+          <a:bodyPr rtlCol="0" anchor="ctr" lIns="0" rIns="0" tIns="0" bIns="0"/>
           <a:lstStyle/>
           <a:p>
             <a:pPr algn="ctr">
@@ -3502,7 +3498,7 @@
           </a:fontRef>
         </p:style>
         <p:txBody>
-          <a:bodyPr lIns="0" tIns="0" rIns="0" bIns="0" rtlCol="0" anchor="ctr"/>
+          <a:bodyPr rtlCol="0" anchor="ctr" lIns="0" rIns="0" tIns="0" bIns="0"/>
           <a:lstStyle/>
           <a:p>
             <a:pPr algn="ctr">
@@ -3513,7 +3509,7 @@
               </a:defRPr>
             </a:pPr>
             <a:r>
-              <a:t>MONTH-1 CHURN DROP</a:t>
+              <a:t>NOT BACK IN MONTH 1</a:t>
             </a:r>
           </a:p>
           <a:p>
@@ -3525,7 +3521,7 @@
               </a:defRPr>
             </a:pPr>
             <a:r>
-              <a:t>-74.2%</a:t>
+              <a:t>76.9%</a:t>
             </a:r>
           </a:p>
         </p:txBody>
@@ -3539,7 +3535,7 @@
 </file>
 
 <file path=ppt/slides/slide2.xml><?xml version="1.0" encoding="utf-8"?>
-<p:sld xmlns:a="http://schemas.openxmlformats.org/drawingml/2006/main" xmlns:r="http://schemas.openxmlformats.org/officeDocument/2006/relationships" xmlns:p="http://schemas.openxmlformats.org/presentationml/2006/main">
+<p:sld xmlns:a="http://schemas.openxmlformats.org/drawingml/2006/main" xmlns:p="http://schemas.openxmlformats.org/presentationml/2006/main" xmlns:r="http://schemas.openxmlformats.org/officeDocument/2006/relationships">
   <p:cSld>
     <p:spTree>
       <p:nvGrpSpPr>
@@ -3547,14 +3543,7 @@
         <p:cNvGrpSpPr/>
         <p:nvPr/>
       </p:nvGrpSpPr>
-      <p:grpSpPr>
-        <a:xfrm>
-          <a:off x="0" y="0"/>
-          <a:ext cx="0" cy="0"/>
-          <a:chOff x="0" y="0"/>
-          <a:chExt cx="0" cy="0"/>
-        </a:xfrm>
-      </p:grpSpPr>
+      <p:grpSpPr/>
       <p:sp>
         <p:nvSpPr>
           <p:cNvPr id="2" name="Rectangle 1"/>
@@ -3595,7 +3584,6 @@
           <a:lstStyle/>
           <a:p>
             <a:pPr algn="ctr"/>
-            <a:endParaRPr/>
           </a:p>
         </p:txBody>
       </p:sp>
@@ -3637,7 +3625,7 @@
           </a:fontRef>
         </p:style>
         <p:txBody>
-          <a:bodyPr lIns="0" tIns="0" rIns="0" bIns="0" rtlCol="0" anchor="ctr"/>
+          <a:bodyPr rtlCol="0" anchor="ctr" lIns="0" rIns="0" tIns="0" bIns="0"/>
           <a:lstStyle/>
           <a:p>
             <a:pPr algn="ctr">
@@ -3670,7 +3658,7 @@
           <a:noFill/>
         </p:spPr>
         <p:txBody>
-          <a:bodyPr wrap="none" lIns="0" tIns="0" rIns="0" bIns="0">
+          <a:bodyPr wrap="none" lIns="0" rIns="0" tIns="0" bIns="0">
             <a:spAutoFit/>
           </a:bodyPr>
           <a:lstStyle/>
@@ -3726,7 +3714,7 @@
           </a:fontRef>
         </p:style>
         <p:txBody>
-          <a:bodyPr lIns="164592" tIns="0" rIns="164592" bIns="0" rtlCol="0" anchor="ctr"/>
+          <a:bodyPr rtlCol="0" anchor="ctr" lIns="164592" rIns="164592" tIns="0" bIns="0"/>
           <a:lstStyle/>
           <a:p>
             <a:pPr algn="ctr">
@@ -3737,8 +3725,7 @@
               </a:defRPr>
             </a:pPr>
             <a:r>
-              <a:rPr dirty="0"/>
-              <a:t>TOTAL GROSS REVENUE</a:t>
+              <a:t>TOTAL REVENUE</a:t>
             </a:r>
           </a:p>
           <a:p>
@@ -3768,8 +3755,7 @@
               </a:defRPr>
             </a:pPr>
             <a:r>
-              <a:rPr dirty="0"/>
-              <a:t>Net valid transactions (24 Months)</a:t>
+              <a:t>36,969 orders, Dec 2009 - Dec 2011</a:t>
             </a:r>
           </a:p>
         </p:txBody>
@@ -3812,7 +3798,7 @@
           </a:fontRef>
         </p:style>
         <p:txBody>
-          <a:bodyPr lIns="164592" tIns="0" rIns="164592" bIns="0" rtlCol="0" anchor="ctr"/>
+          <a:bodyPr rtlCol="0" anchor="ctr" lIns="164592" rIns="164592" tIns="0" bIns="0"/>
           <a:lstStyle/>
           <a:p>
             <a:pPr algn="ctr">
@@ -3823,7 +3809,7 @@
               </a:defRPr>
             </a:pPr>
             <a:r>
-              <a:t>REGISTERED BUYERS</a:t>
+              <a:t>REGISTERED CUSTOMERS</a:t>
             </a:r>
           </a:p>
           <a:p>
@@ -3853,7 +3839,7 @@
               </a:defRPr>
             </a:pPr>
             <a:r>
-              <a:t>Tracked unique customer IDs</a:t>
+              <a:t>41 countries</a:t>
             </a:r>
           </a:p>
         </p:txBody>
@@ -3896,7 +3882,7 @@
           </a:fontRef>
         </p:style>
         <p:txBody>
-          <a:bodyPr lIns="164592" tIns="0" rIns="164592" bIns="0" rtlCol="0" anchor="ctr"/>
+          <a:bodyPr rtlCol="0" anchor="ctr" lIns="164592" rIns="164592" tIns="0" bIns="0"/>
           <a:lstStyle/>
           <a:p>
             <a:pPr algn="ctr">
@@ -3922,7 +3908,7 @@
               </a:defRPr>
             </a:pPr>
             <a:r>
-              <a:t>25.8%</a:t>
+              <a:t>23.1%</a:t>
             </a:r>
           </a:p>
           <a:p>
@@ -3937,7 +3923,7 @@
               </a:defRPr>
             </a:pPr>
             <a:r>
-              <a:t>Steepest drop-off point in lifecycle</a:t>
+              <a:t>Steepest drop-off in the lifecycle</a:t>
             </a:r>
           </a:p>
         </p:txBody>
@@ -3980,7 +3966,7 @@
           </a:fontRef>
         </p:style>
         <p:txBody>
-          <a:bodyPr lIns="164592" tIns="0" rIns="164592" bIns="0" rtlCol="0" anchor="ctr"/>
+          <a:bodyPr rtlCol="0" anchor="ctr" lIns="164592" rIns="164592" tIns="0" bIns="0"/>
           <a:lstStyle/>
           <a:p>
             <a:pPr algn="ctr">
@@ -3991,7 +3977,7 @@
               </a:defRPr>
             </a:pPr>
             <a:r>
-              <a:t>TOP VALUE CONCENTRATION</a:t>
+              <a:t>CHAMPIONS + LOYAL REVENUE</a:t>
             </a:r>
           </a:p>
           <a:p>
@@ -4006,7 +3992,7 @@
               </a:defRPr>
             </a:pPr>
             <a:r>
-              <a:t>62.4%</a:t>
+              <a:t>84.7%</a:t>
             </a:r>
           </a:p>
           <a:p>
@@ -4021,7 +4007,7 @@
               </a:defRPr>
             </a:pPr>
             <a:r>
-              <a:t>Driven by top 28.1% of customers</a:t>
+              <a:t>From 43.1% of customers</a:t>
             </a:r>
           </a:p>
         </p:txBody>
@@ -4064,7 +4050,7 @@
           </a:fontRef>
         </p:style>
         <p:txBody>
-          <a:bodyPr wrap="square" lIns="228600" tIns="182880" rIns="228600" bIns="137160" rtlCol="0" anchor="ctr"/>
+          <a:bodyPr rtlCol="0" anchor="ctr" wrap="square" lIns="228600" rIns="228600" tIns="182880" bIns="137160"/>
           <a:lstStyle/>
           <a:p>
             <a:pPr algn="ctr">
@@ -4086,7 +4072,7 @@
               <a:spcBef>
                 <a:spcPts val="600"/>
               </a:spcBef>
-              <a:defRPr sz="950" b="1">
+              <a:defRPr b="1" sz="950">
                 <a:solidFill>
                   <a:srgbClr val="0F172A"/>
                 </a:solidFill>
@@ -4116,7 +4102,7 @@
               <a:spcBef>
                 <a:spcPts val="600"/>
               </a:spcBef>
-              <a:defRPr sz="950" b="1">
+              <a:defRPr b="1" sz="950">
                 <a:solidFill>
                   <a:srgbClr val="0F172A"/>
                 </a:solidFill>
@@ -4146,14 +4132,14 @@
               <a:spcBef>
                 <a:spcPts val="600"/>
               </a:spcBef>
-              <a:defRPr sz="950" b="1">
+              <a:defRPr b="1" sz="950">
                 <a:solidFill>
                   <a:srgbClr val="0F172A"/>
                 </a:solidFill>
               </a:defRPr>
             </a:pPr>
             <a:r>
-              <a:t>• The 'Month-1 Cliff' (74.2% Churn): </a:t>
+              <a:t>• The Month-1 Cliff (76.9% not back): </a:t>
             </a:r>
           </a:p>
           <a:p>
@@ -4168,7 +4154,7 @@
               </a:defRPr>
             </a:pPr>
             <a:r>
-              <a:t>  Almost three-quarters of buyers lapse immediately after order #1 due to lack of automated onboarding.</a:t>
+              <a:t>  Roughly three in four new customers do not buy again in the month after their first order.</a:t>
             </a:r>
           </a:p>
           <a:p>
@@ -4176,7 +4162,7 @@
               <a:spcBef>
                 <a:spcPts val="600"/>
               </a:spcBef>
-              <a:defRPr sz="950" b="1">
+              <a:defRPr b="1" sz="950">
                 <a:solidFill>
                   <a:srgbClr val="0F172A"/>
                 </a:solidFill>
@@ -4198,7 +4184,7 @@
               </a:defRPr>
             </a:pPr>
             <a:r>
-              <a:t>  High-value buyers lapsed into 'At Risk' unnoticed without automated behavioral retention triggers.</a:t>
+              <a:t>  683 once-valuable customers (£1.71M historical revenue) have drifted into At Risk.</a:t>
             </a:r>
           </a:p>
         </p:txBody>
@@ -4241,7 +4227,7 @@
           </a:fontRef>
         </p:style>
         <p:txBody>
-          <a:bodyPr wrap="square" lIns="228600" tIns="182880" rIns="228600" bIns="137160" rtlCol="0" anchor="ctr"/>
+          <a:bodyPr rtlCol="0" anchor="ctr" wrap="square" lIns="228600" rIns="228600" tIns="182880" bIns="137160"/>
           <a:lstStyle/>
           <a:p>
             <a:pPr algn="ctr">
@@ -4263,7 +4249,7 @@
               <a:spcBef>
                 <a:spcPts val="600"/>
               </a:spcBef>
-              <a:defRPr sz="950" b="1">
+              <a:defRPr b="1" sz="950">
                 <a:solidFill>
                   <a:srgbClr val="0F172A"/>
                 </a:solidFill>
@@ -4293,7 +4279,7 @@
               <a:spcBef>
                 <a:spcPts val="600"/>
               </a:spcBef>
-              <a:defRPr sz="950" b="1">
+              <a:defRPr b="1" sz="950">
                 <a:solidFill>
                   <a:srgbClr val="0F172A"/>
                 </a:solidFill>
@@ -4323,14 +4309,14 @@
               <a:spcBef>
                 <a:spcPts val="600"/>
               </a:spcBef>
-              <a:defRPr sz="950" b="1">
+              <a:defRPr b="1" sz="950">
                 <a:solidFill>
                   <a:srgbClr val="0F172A"/>
                 </a:solidFill>
               </a:defRPr>
             </a:pPr>
             <a:r>
-              <a:t>• Bridge Month-1 Gap (Days 7-21): </a:t>
+              <a:t>• Bridge the Month-1 Gap: </a:t>
             </a:r>
           </a:p>
           <a:p>
@@ -4345,7 +4331,7 @@
               </a:defRPr>
             </a:pPr>
             <a:r>
-              <a:t>  Target new buyers with personalized category recommendations within 14 days to lift repeat rates above 35%.</a:t>
+              <a:t>  Send new buyers personalised category recommendations within 14 days of their first order.</a:t>
             </a:r>
           </a:p>
           <a:p>
@@ -4353,14 +4339,14 @@
               <a:spcBef>
                 <a:spcPts val="600"/>
               </a:spcBef>
-              <a:defRPr sz="950" b="1">
+              <a:defRPr b="1" sz="950">
                 <a:solidFill>
                   <a:srgbClr val="0F172A"/>
                 </a:solidFill>
               </a:defRPr>
             </a:pPr>
             <a:r>
-              <a:t>• Automate Live Tableau Telemetry: </a:t>
+              <a:t>• Track Retention in Power BI: </a:t>
             </a:r>
           </a:p>
           <a:p>
@@ -4375,7 +4361,7 @@
               </a:defRPr>
             </a:pPr>
             <a:r>
-              <a:t>  Empower growth teams with live weekly cohort retention and RFM migration dashboards.</a:t>
+              <a:t>  Give growth teams a dashboard for month-1 retention, cohort curves and segment shifts.</a:t>
             </a:r>
           </a:p>
         </p:txBody>
@@ -4389,7 +4375,7 @@
 </file>
 
 <file path=ppt/slides/slide3.xml><?xml version="1.0" encoding="utf-8"?>
-<p:sld xmlns:a="http://schemas.openxmlformats.org/drawingml/2006/main" xmlns:r="http://schemas.openxmlformats.org/officeDocument/2006/relationships" xmlns:p="http://schemas.openxmlformats.org/presentationml/2006/main">
+<p:sld xmlns:a="http://schemas.openxmlformats.org/drawingml/2006/main" xmlns:p="http://schemas.openxmlformats.org/presentationml/2006/main" xmlns:r="http://schemas.openxmlformats.org/officeDocument/2006/relationships">
   <p:cSld>
     <p:spTree>
       <p:nvGrpSpPr>
@@ -4397,14 +4383,7 @@
         <p:cNvGrpSpPr/>
         <p:nvPr/>
       </p:nvGrpSpPr>
-      <p:grpSpPr>
-        <a:xfrm>
-          <a:off x="0" y="0"/>
-          <a:ext cx="0" cy="0"/>
-          <a:chOff x="0" y="0"/>
-          <a:chExt cx="0" cy="0"/>
-        </a:xfrm>
-      </p:grpSpPr>
+      <p:grpSpPr/>
       <p:sp>
         <p:nvSpPr>
           <p:cNvPr id="2" name="Rectangle 1"/>
@@ -4445,7 +4424,6 @@
           <a:lstStyle/>
           <a:p>
             <a:pPr algn="ctr"/>
-            <a:endParaRPr/>
           </a:p>
         </p:txBody>
       </p:sp>
@@ -4487,7 +4465,7 @@
           </a:fontRef>
         </p:style>
         <p:txBody>
-          <a:bodyPr lIns="0" tIns="0" rIns="0" bIns="0" rtlCol="0" anchor="ctr"/>
+          <a:bodyPr rtlCol="0" anchor="ctr" lIns="0" rIns="0" tIns="0" bIns="0"/>
           <a:lstStyle/>
           <a:p>
             <a:pPr algn="ctr">
@@ -4520,7 +4498,7 @@
           <a:noFill/>
         </p:spPr>
         <p:txBody>
-          <a:bodyPr wrap="none" lIns="0" tIns="0" rIns="0" bIns="0">
+          <a:bodyPr wrap="none" lIns="0" rIns="0" tIns="0" bIns="0">
             <a:spAutoFit/>
           </a:bodyPr>
           <a:lstStyle/>
@@ -4580,7 +4558,6 @@
           <a:lstStyle/>
           <a:p>
             <a:pPr algn="ctr"/>
-            <a:endParaRPr/>
           </a:p>
         </p:txBody>
       </p:sp>
@@ -4600,7 +4577,7 @@
         </p:blipFill>
         <p:spPr>
           <a:xfrm>
-            <a:off x="868680" y="1946462"/>
+            <a:off x="868680" y="1371600"/>
             <a:ext cx="6583680" cy="3603946"/>
           </a:xfrm>
           <a:prstGeom prst="rect">
@@ -4646,7 +4623,7 @@
           </a:fontRef>
         </p:style>
         <p:txBody>
-          <a:bodyPr wrap="square" lIns="164592" tIns="137160" rIns="164592" bIns="91440" rtlCol="0" anchor="ctr"/>
+          <a:bodyPr rtlCol="0" anchor="ctr" wrap="square" lIns="164592" rIns="164592" tIns="137160" bIns="91440"/>
           <a:lstStyle/>
           <a:p>
             <a:pPr algn="ctr">
@@ -4660,7 +4637,7 @@
               </a:defRPr>
             </a:pPr>
             <a:r>
-              <a:t>THE MONTH-1 CLIFF (-74.2% DROP)</a:t>
+              <a:t>THE MONTH-1 CLIFF (23.1% RETAINED)</a:t>
             </a:r>
           </a:p>
           <a:p>
@@ -4675,7 +4652,7 @@
               </a:defRPr>
             </a:pPr>
             <a:r>
-              <a:t>Average retention plummets from 100% to 25.8% within 30 days. Over 7 out of 10 newly acquired customers never make a repeat purchase without intervention.</a:t>
+              <a:t>Only 23.1% of new customers buy again in the month after their first order (customer-weighted across all cohorts).</a:t>
             </a:r>
           </a:p>
         </p:txBody>
@@ -4718,7 +4695,7 @@
           </a:fontRef>
         </p:style>
         <p:txBody>
-          <a:bodyPr wrap="square" lIns="164592" tIns="137160" rIns="164592" bIns="91440" rtlCol="0" anchor="ctr"/>
+          <a:bodyPr rtlCol="0" anchor="ctr" wrap="square" lIns="164592" rIns="164592" tIns="137160" bIns="91440"/>
           <a:lstStyle/>
           <a:p>
             <a:pPr algn="ctr">
@@ -4732,7 +4709,7 @@
               </a:defRPr>
             </a:pPr>
             <a:r>
-              <a:t>LONG-TERM RETENTION STABILIZATION</a:t>
+              <a:t>FLAT AFTER THE CLIFF</a:t>
             </a:r>
           </a:p>
           <a:p>
@@ -4747,7 +4724,7 @@
               </a:defRPr>
             </a:pPr>
             <a:r>
-              <a:t>Cohorts that survive past Month 3 form a resilient, highly profitable core, sustaining 20-25% repeat activity through Month 12+.</a:t>
+              <a:t>Retention then holds between 19.0% and 24.5% from month 1 to month 12, so the second purchase is the main lever.</a:t>
             </a:r>
           </a:p>
         </p:txBody>
@@ -4790,7 +4767,7 @@
           </a:fontRef>
         </p:style>
         <p:txBody>
-          <a:bodyPr wrap="square" lIns="164592" tIns="137160" rIns="164592" bIns="91440" rtlCol="0" anchor="ctr"/>
+          <a:bodyPr rtlCol="0" anchor="ctr" wrap="square" lIns="164592" rIns="164592" tIns="137160" bIns="91440"/>
           <a:lstStyle/>
           <a:p>
             <a:pPr algn="ctr">
@@ -4804,7 +4781,7 @@
               </a:defRPr>
             </a:pPr>
             <a:r>
-              <a:t>CRITICAL INTERVENTION WINDOW</a:t>
+              <a:t>HOLIDAY COHORTS RETAIN WORST</a:t>
             </a:r>
           </a:p>
           <a:p>
@@ -4819,7 +4796,7 @@
               </a:defRPr>
             </a:pPr>
             <a:r>
-              <a:t>Post-purchase onboarding triggers must deploy during Days 7-21 while product satisfaction is high, before buyer momentum completely fades.</a:t>
+              <a:t>Customers first acquired in Nov 2010 (17.5%) and Dec 2010 (9.2%) came back far less in month 1. Follow up within 30 days.</a:t>
             </a:r>
           </a:p>
         </p:txBody>
@@ -4833,7 +4810,7 @@
 </file>
 
 <file path=ppt/slides/slide4.xml><?xml version="1.0" encoding="utf-8"?>
-<p:sld xmlns:a="http://schemas.openxmlformats.org/drawingml/2006/main" xmlns:r="http://schemas.openxmlformats.org/officeDocument/2006/relationships" xmlns:p="http://schemas.openxmlformats.org/presentationml/2006/main">
+<p:sld xmlns:a="http://schemas.openxmlformats.org/drawingml/2006/main" xmlns:p="http://schemas.openxmlformats.org/presentationml/2006/main" xmlns:r="http://schemas.openxmlformats.org/officeDocument/2006/relationships">
   <p:cSld>
     <p:spTree>
       <p:nvGrpSpPr>
@@ -4841,14 +4818,7 @@
         <p:cNvGrpSpPr/>
         <p:nvPr/>
       </p:nvGrpSpPr>
-      <p:grpSpPr>
-        <a:xfrm>
-          <a:off x="0" y="0"/>
-          <a:ext cx="0" cy="0"/>
-          <a:chOff x="0" y="0"/>
-          <a:chExt cx="0" cy="0"/>
-        </a:xfrm>
-      </p:grpSpPr>
+      <p:grpSpPr/>
       <p:sp>
         <p:nvSpPr>
           <p:cNvPr id="2" name="Rectangle 1"/>
@@ -4889,7 +4859,6 @@
           <a:lstStyle/>
           <a:p>
             <a:pPr algn="ctr"/>
-            <a:endParaRPr/>
           </a:p>
         </p:txBody>
       </p:sp>
@@ -4931,7 +4900,7 @@
           </a:fontRef>
         </p:style>
         <p:txBody>
-          <a:bodyPr lIns="0" tIns="0" rIns="0" bIns="0" rtlCol="0" anchor="ctr"/>
+          <a:bodyPr rtlCol="0" anchor="ctr" lIns="0" rIns="0" tIns="0" bIns="0"/>
           <a:lstStyle/>
           <a:p>
             <a:pPr algn="ctr">
@@ -4964,7 +4933,7 @@
           <a:noFill/>
         </p:spPr>
         <p:txBody>
-          <a:bodyPr wrap="none" lIns="0" tIns="0" rIns="0" bIns="0">
+          <a:bodyPr wrap="none" lIns="0" rIns="0" tIns="0" bIns="0">
             <a:spAutoFit/>
           </a:bodyPr>
           <a:lstStyle/>
@@ -5024,7 +4993,6 @@
           <a:lstStyle/>
           <a:p>
             <a:pPr algn="ctr"/>
-            <a:endParaRPr/>
           </a:p>
         </p:txBody>
       </p:sp>
@@ -5044,8 +5012,8 @@
         </p:blipFill>
         <p:spPr>
           <a:xfrm>
-            <a:off x="868680" y="2127642"/>
-            <a:ext cx="6583680" cy="2985932"/>
+            <a:off x="868680" y="1371600"/>
+            <a:ext cx="6583680" cy="3391593"/>
           </a:xfrm>
           <a:prstGeom prst="rect">
             <a:avLst/>
@@ -5090,7 +5058,7 @@
           </a:fontRef>
         </p:style>
         <p:txBody>
-          <a:bodyPr wrap="square" lIns="164592" tIns="137160" rIns="164592" bIns="91440" rtlCol="0" anchor="ctr"/>
+          <a:bodyPr rtlCol="0" anchor="ctr" wrap="square" lIns="164592" rIns="164592" tIns="137160" bIns="91440"/>
           <a:lstStyle/>
           <a:p>
             <a:pPr algn="ctr">
@@ -5104,7 +5072,7 @@
               </a:defRPr>
             </a:pPr>
             <a:r>
-              <a:t>CHAMPIONS (41.1% REVENUE | 14.8% USERS)</a:t>
+              <a:t>CHAMPIONS (69.0% REVENUE | 22.5% CUSTOMERS)</a:t>
             </a:r>
           </a:p>
           <a:p>
@@ -5119,7 +5087,7 @@
               </a:defRPr>
             </a:pPr>
             <a:r>
-              <a:t>868 VIPs generate £7.28M with 19.8 avg orders (£8.39k spend). Action: Provide dedicated concierge, product co-creation, and zero margin discounts.</a:t>
+              <a:t>1,324 customers generate £12.24M with 16.9 orders on average (£9,246 spend). Action: VIP perks and early access, no discounts.</a:t>
             </a:r>
           </a:p>
         </p:txBody>
@@ -5162,7 +5130,7 @@
           </a:fontRef>
         </p:style>
         <p:txBody>
-          <a:bodyPr wrap="square" lIns="164592" tIns="137160" rIns="164592" bIns="91440" rtlCol="0" anchor="ctr"/>
+          <a:bodyPr rtlCol="0" anchor="ctr" wrap="square" lIns="164592" rIns="164592" tIns="137160" bIns="91440"/>
           <a:lstStyle/>
           <a:p>
             <a:pPr algn="ctr">
@@ -5176,7 +5144,7 @@
               </a:defRPr>
             </a:pPr>
             <a:r>
-              <a:t>LOYAL &amp; POTENTIAL (29.5% REVENUE)</a:t>
+              <a:t>LOYAL &amp; POTENTIAL (17.4% REVENUE)</a:t>
             </a:r>
           </a:p>
           <a:p>
@@ -5191,7 +5159,7 @@
               </a:defRPr>
             </a:pPr>
             <a:r>
-              <a:t>1,523 consistent buyers contributing £5.23M. Action: Milestone rewards, threshold spend bonuses, and cross-category discovery recommendations.</a:t>
+              <a:t>1,842 customers contributing £3.09M. Action: loyalty milestones and cross-category recommendations.</a:t>
             </a:r>
           </a:p>
         </p:txBody>
@@ -5234,7 +5202,7 @@
           </a:fontRef>
         </p:style>
         <p:txBody>
-          <a:bodyPr wrap="square" lIns="164592" tIns="137160" rIns="164592" bIns="91440" rtlCol="0" anchor="ctr"/>
+          <a:bodyPr rtlCol="0" anchor="ctr" wrap="square" lIns="164592" rIns="164592" tIns="137160" bIns="91440"/>
           <a:lstStyle/>
           <a:p>
             <a:pPr algn="ctr">
@@ -5248,7 +5216,7 @@
               </a:defRPr>
             </a:pPr>
             <a:r>
-              <a:t>AT RISK &amp; CAN'T LOSE (15.1% REVENUE)</a:t>
+              <a:t>AT RISK (9.6% REVENUE)</a:t>
             </a:r>
           </a:p>
           <a:p>
@@ -5263,7 +5231,7 @@
               </a:defRPr>
             </a:pPr>
             <a:r>
-              <a:t>945 high-spend customers inactive &gt;200 days (£2.68M revenue at stake). Action: Time-sensitive automated win-back emails &amp; reactivation incentives.</a:t>
+              <a:t>683 customers averaging £2,501 spend, last order ~364 days ago (£1.71M historical revenue). Action: targeted win-back offers.</a:t>
             </a:r>
           </a:p>
         </p:txBody>
@@ -5277,7 +5245,7 @@
 </file>
 
 <file path=ppt/slides/slide5.xml><?xml version="1.0" encoding="utf-8"?>
-<p:sld xmlns:a="http://schemas.openxmlformats.org/drawingml/2006/main" xmlns:r="http://schemas.openxmlformats.org/officeDocument/2006/relationships" xmlns:p="http://schemas.openxmlformats.org/presentationml/2006/main">
+<p:sld xmlns:a="http://schemas.openxmlformats.org/drawingml/2006/main" xmlns:p="http://schemas.openxmlformats.org/presentationml/2006/main" xmlns:r="http://schemas.openxmlformats.org/officeDocument/2006/relationships">
   <p:cSld>
     <p:spTree>
       <p:nvGrpSpPr>
@@ -5285,14 +5253,7 @@
         <p:cNvGrpSpPr/>
         <p:nvPr/>
       </p:nvGrpSpPr>
-      <p:grpSpPr>
-        <a:xfrm>
-          <a:off x="0" y="0"/>
-          <a:ext cx="0" cy="0"/>
-          <a:chOff x="0" y="0"/>
-          <a:chExt cx="0" cy="0"/>
-        </a:xfrm>
-      </p:grpSpPr>
+      <p:grpSpPr/>
       <p:sp>
         <p:nvSpPr>
           <p:cNvPr id="2" name="Rectangle 1"/>
@@ -5333,7 +5294,6 @@
           <a:lstStyle/>
           <a:p>
             <a:pPr algn="ctr"/>
-            <a:endParaRPr/>
           </a:p>
         </p:txBody>
       </p:sp>
@@ -5375,7 +5335,7 @@
           </a:fontRef>
         </p:style>
         <p:txBody>
-          <a:bodyPr lIns="0" tIns="0" rIns="0" bIns="0" rtlCol="0" anchor="ctr"/>
+          <a:bodyPr rtlCol="0" anchor="ctr" lIns="0" rIns="0" tIns="0" bIns="0"/>
           <a:lstStyle/>
           <a:p>
             <a:pPr algn="ctr">
@@ -5408,7 +5368,7 @@
           <a:noFill/>
         </p:spPr>
         <p:txBody>
-          <a:bodyPr wrap="none" lIns="0" tIns="0" rIns="0" bIns="0">
+          <a:bodyPr wrap="none" lIns="0" rIns="0" tIns="0" bIns="0">
             <a:spAutoFit/>
           </a:bodyPr>
           <a:lstStyle/>
@@ -5468,7 +5428,6 @@
           <a:lstStyle/>
           <a:p>
             <a:pPr algn="ctr"/>
-            <a:endParaRPr/>
           </a:p>
         </p:txBody>
       </p:sp>
@@ -5488,7 +5447,7 @@
         </p:blipFill>
         <p:spPr>
           <a:xfrm>
-            <a:off x="868680" y="2022071"/>
+            <a:off x="868680" y="1371600"/>
             <a:ext cx="6583680" cy="3391593"/>
           </a:xfrm>
           <a:prstGeom prst="rect">
@@ -5534,7 +5493,7 @@
           </a:fontRef>
         </p:style>
         <p:txBody>
-          <a:bodyPr wrap="square" lIns="164592" tIns="137160" rIns="164592" bIns="91440" rtlCol="0" anchor="ctr"/>
+          <a:bodyPr rtlCol="0" anchor="ctr" wrap="square" lIns="164592" rIns="164592" tIns="137160" bIns="91440"/>
           <a:lstStyle/>
           <a:p>
             <a:pPr algn="ctr">
@@ -5548,7 +5507,7 @@
               </a:defRPr>
             </a:pPr>
             <a:r>
-              <a:t>Q4 HOLIDAY REVENUE SURGE (&gt;£1.5M/MO)</a:t>
+              <a:t>Q4 PEAK (~£1.2M / MONTH)</a:t>
             </a:r>
           </a:p>
           <a:p>
@@ -5563,7 +5522,7 @@
               </a:defRPr>
             </a:pPr>
             <a:r>
-              <a:t>Consistent seasonal peaks in October-November where monthly revenue spikes +140% above Q1 levels, driven by seasonal gifting volume.</a:t>
+              <a:t>Revenue climbs from September and peaks in November in both years, roughly twice the Q1 monthly level.</a:t>
             </a:r>
           </a:p>
         </p:txBody>
@@ -5606,7 +5565,7 @@
           </a:fontRef>
         </p:style>
         <p:txBody>
-          <a:bodyPr wrap="square" lIns="164592" tIns="137160" rIns="164592" bIns="91440" rtlCol="0" anchor="ctr"/>
+          <a:bodyPr rtlCol="0" anchor="ctr" wrap="square" lIns="164592" rIns="164592" tIns="137160" bIns="91440"/>
           <a:lstStyle/>
           <a:p>
             <a:pPr algn="ctr">
@@ -5620,7 +5579,7 @@
               </a:defRPr>
             </a:pPr>
             <a:r>
-              <a:t>POST-HOLIDAY CHURN MANAGEMENT</a:t>
+              <a:t>POST-HOLIDAY RE-ENGAGEMENT</a:t>
             </a:r>
           </a:p>
           <a:p>
@@ -5635,7 +5594,7 @@
               </a:defRPr>
             </a:pPr>
             <a:r>
-              <a:t>The huge influx of November buyers requires structured January re-engagement sequences to prevent them from becoming dormant Hibernators.</a:t>
+              <a:t>Holiday first-time buyers retain worst, so a January re-engagement flow keeps them from becoming Hibernating.</a:t>
             </a:r>
           </a:p>
         </p:txBody>
@@ -5678,7 +5637,7 @@
           </a:fontRef>
         </p:style>
         <p:txBody>
-          <a:bodyPr wrap="square" lIns="164592" tIns="137160" rIns="164592" bIns="91440" rtlCol="0" anchor="ctr"/>
+          <a:bodyPr rtlCol="0" anchor="ctr" wrap="square" lIns="164592" rIns="164592" tIns="137160" bIns="91440"/>
           <a:lstStyle/>
           <a:p>
             <a:pPr algn="ctr">
@@ -5692,7 +5651,7 @@
               </a:defRPr>
             </a:pPr>
             <a:r>
-              <a:t>BASKET MONETIZATION &amp; AOV EXPANSION</a:t>
+              <a:t>DECEMBER 2011 IS PARTIAL</a:t>
             </a:r>
           </a:p>
           <a:p>
@@ -5707,7 +5666,7 @@
               </a:defRPr>
             </a:pPr>
             <a:r>
-              <a:t>Average Order Value (AOV) reaches maximum levels during multi-item holiday purchasing. Automated bundle recommendations maximize transaction value.</a:t>
+              <a:t>The data ends on 9 Dec 2011, so the final drop is a cut-off, not a decline. Average order value over the period: £480.</a:t>
             </a:r>
           </a:p>
         </p:txBody>
@@ -5721,7 +5680,7 @@
 </file>
 
 <file path=ppt/slides/slide6.xml><?xml version="1.0" encoding="utf-8"?>
-<p:sld xmlns:a="http://schemas.openxmlformats.org/drawingml/2006/main" xmlns:r="http://schemas.openxmlformats.org/officeDocument/2006/relationships" xmlns:p="http://schemas.openxmlformats.org/presentationml/2006/main">
+<p:sld xmlns:a="http://schemas.openxmlformats.org/drawingml/2006/main" xmlns:p="http://schemas.openxmlformats.org/presentationml/2006/main" xmlns:r="http://schemas.openxmlformats.org/officeDocument/2006/relationships">
   <p:cSld>
     <p:spTree>
       <p:nvGrpSpPr>
@@ -5729,14 +5688,7 @@
         <p:cNvGrpSpPr/>
         <p:nvPr/>
       </p:nvGrpSpPr>
-      <p:grpSpPr>
-        <a:xfrm>
-          <a:off x="0" y="0"/>
-          <a:ext cx="0" cy="0"/>
-          <a:chOff x="0" y="0"/>
-          <a:chExt cx="0" cy="0"/>
-        </a:xfrm>
-      </p:grpSpPr>
+      <p:grpSpPr/>
       <p:sp>
         <p:nvSpPr>
           <p:cNvPr id="2" name="Rectangle 1"/>
@@ -5777,7 +5729,6 @@
           <a:lstStyle/>
           <a:p>
             <a:pPr algn="ctr"/>
-            <a:endParaRPr/>
           </a:p>
         </p:txBody>
       </p:sp>
@@ -5819,7 +5770,7 @@
           </a:fontRef>
         </p:style>
         <p:txBody>
-          <a:bodyPr lIns="0" tIns="0" rIns="0" bIns="0" rtlCol="0" anchor="ctr"/>
+          <a:bodyPr rtlCol="0" anchor="ctr" lIns="0" rIns="0" tIns="0" bIns="0"/>
           <a:lstStyle/>
           <a:p>
             <a:pPr algn="ctr">
@@ -5852,7 +5803,7 @@
           <a:noFill/>
         </p:spPr>
         <p:txBody>
-          <a:bodyPr wrap="none" lIns="0" tIns="0" rIns="0" bIns="0">
+          <a:bodyPr wrap="none" lIns="0" rIns="0" tIns="0" bIns="0">
             <a:spAutoFit/>
           </a:bodyPr>
           <a:lstStyle/>
@@ -5908,7 +5859,7 @@
           </a:fontRef>
         </p:style>
         <p:txBody>
-          <a:bodyPr wrap="square" lIns="182880" tIns="182880" rIns="182880" bIns="137160" rtlCol="0" anchor="ctr"/>
+          <a:bodyPr rtlCol="0" anchor="ctr" wrap="square" lIns="182880" rIns="182880" tIns="182880" bIns="137160"/>
           <a:lstStyle/>
           <a:p>
             <a:pPr algn="ctr">
@@ -6027,7 +5978,7 @@
               </a:defRPr>
             </a:pPr>
             <a:r>
-              <a:t>• Target CAC Reduction (-15%)</a:t>
+              <a:t>• Measure with Holdout Tests</a:t>
             </a:r>
           </a:p>
           <a:p>
@@ -6042,7 +5993,7 @@
               </a:defRPr>
             </a:pPr>
             <a:r>
-              <a:t>  Lower blended acquisition costs by boosting repeat purchase contribution.</a:t>
+              <a:t>  Run each change against a control group to measure its real effect on repeat revenue and CAC.</a:t>
             </a:r>
           </a:p>
         </p:txBody>
@@ -6085,7 +6036,7 @@
           </a:fontRef>
         </p:style>
         <p:txBody>
-          <a:bodyPr wrap="square" lIns="182880" tIns="182880" rIns="182880" bIns="137160" rtlCol="0" anchor="ctr"/>
+          <a:bodyPr rtlCol="0" anchor="ctr" wrap="square" lIns="182880" rIns="182880" tIns="182880" bIns="137160"/>
           <a:lstStyle/>
           <a:p>
             <a:pPr algn="ctr">
@@ -6262,7 +6213,7 @@
           </a:fontRef>
         </p:style>
         <p:txBody>
-          <a:bodyPr wrap="square" lIns="182880" tIns="182880" rIns="182880" bIns="137160" rtlCol="0" anchor="ctr"/>
+          <a:bodyPr rtlCol="0" anchor="ctr" wrap="square" lIns="182880" rIns="182880" tIns="182880" bIns="137160"/>
           <a:lstStyle/>
           <a:p>
             <a:pPr algn="ctr">
@@ -6351,7 +6302,7 @@
               </a:defRPr>
             </a:pPr>
             <a:r>
-              <a:t>• Tableau Retention Tracking</a:t>
+              <a:t>• Power BI Retention Dashboard</a:t>
             </a:r>
           </a:p>
           <a:p>
@@ -6366,7 +6317,7 @@
               </a:defRPr>
             </a:pPr>
             <a:r>
-              <a:t>  Connect Tableau dashboards via automated TDS / ODBC connection for live weekly cohort monitoring.</a:t>
+              <a:t>  Monitor month-1 retention, cohort curves and segment shifts in the three-page Power BI report.</a:t>
             </a:r>
           </a:p>
           <a:p>
@@ -6410,7 +6361,7 @@
 </file>
 
 <file path=ppt/slides/slide7.xml><?xml version="1.0" encoding="utf-8"?>
-<p:sld xmlns:a="http://schemas.openxmlformats.org/drawingml/2006/main" xmlns:r="http://schemas.openxmlformats.org/officeDocument/2006/relationships" xmlns:p="http://schemas.openxmlformats.org/presentationml/2006/main">
+<p:sld xmlns:a="http://schemas.openxmlformats.org/drawingml/2006/main" xmlns:p="http://schemas.openxmlformats.org/presentationml/2006/main" xmlns:r="http://schemas.openxmlformats.org/officeDocument/2006/relationships">
   <p:cSld>
     <p:spTree>
       <p:nvGrpSpPr>
@@ -6418,14 +6369,7 @@
         <p:cNvGrpSpPr/>
         <p:nvPr/>
       </p:nvGrpSpPr>
-      <p:grpSpPr>
-        <a:xfrm>
-          <a:off x="0" y="0"/>
-          <a:ext cx="0" cy="0"/>
-          <a:chOff x="0" y="0"/>
-          <a:chExt cx="0" cy="0"/>
-        </a:xfrm>
-      </p:grpSpPr>
+      <p:grpSpPr/>
       <p:sp>
         <p:nvSpPr>
           <p:cNvPr id="2" name="Rectangle 1"/>
@@ -6466,7 +6410,6 @@
           <a:lstStyle/>
           <a:p>
             <a:pPr algn="ctr"/>
-            <a:endParaRPr/>
           </a:p>
         </p:txBody>
       </p:sp>
@@ -6508,7 +6451,7 @@
           </a:fontRef>
         </p:style>
         <p:txBody>
-          <a:bodyPr lIns="0" tIns="0" rIns="0" bIns="0" rtlCol="0" anchor="ctr"/>
+          <a:bodyPr rtlCol="0" anchor="ctr" lIns="0" rIns="0" tIns="0" bIns="0"/>
           <a:lstStyle/>
           <a:p>
             <a:pPr algn="ctr">
@@ -6541,7 +6484,7 @@
           <a:noFill/>
         </p:spPr>
         <p:txBody>
-          <a:bodyPr wrap="none" lIns="0" tIns="0" rIns="0" bIns="0">
+          <a:bodyPr wrap="none" lIns="0" rIns="0" tIns="0" bIns="0">
             <a:spAutoFit/>
           </a:bodyPr>
           <a:lstStyle/>
@@ -6597,7 +6540,7 @@
           </a:fontRef>
         </p:style>
         <p:txBody>
-          <a:bodyPr wrap="square" lIns="164592" tIns="182880" rIns="164592" bIns="137160" rtlCol="0" anchor="ctr"/>
+          <a:bodyPr rtlCol="0" anchor="ctr" wrap="square" lIns="164592" rIns="164592" tIns="182880" bIns="137160"/>
           <a:lstStyle/>
           <a:p>
             <a:pPr algn="ctr">
@@ -6626,7 +6569,7 @@
               </a:defRPr>
             </a:pPr>
             <a:r>
-              <a:t>• Processed 1.06M raw Excel transactions across 2 historical sheets.</a:t>
+              <a:t>• Processed 1.07M raw Excel lines across 2 yearly sheets.</a:t>
             </a:r>
           </a:p>
           <a:p>
@@ -6641,7 +6584,7 @@
               </a:defRPr>
             </a:pPr>
             <a:r>
-              <a:t>• Filtered cancellations ('C'), negative quantities, and zero unit prices.</a:t>
+              <a:t>• Removed cancellations ('C'), returns, zero prices and guest checkouts.</a:t>
             </a:r>
           </a:p>
           <a:p>
@@ -6656,7 +6599,7 @@
               </a:defRPr>
             </a:pPr>
             <a:r>
-              <a:t>• Resulted in 805,549 verified line items with £17.74M revenue.</a:t>
+              <a:t>• Kept 805,549 line items, £17.74M revenue.</a:t>
             </a:r>
           </a:p>
         </p:txBody>
@@ -6699,7 +6642,7 @@
           </a:fontRef>
         </p:style>
         <p:txBody>
-          <a:bodyPr wrap="square" lIns="164592" tIns="182880" rIns="164592" bIns="137160" rtlCol="0" anchor="ctr"/>
+          <a:bodyPr rtlCol="0" anchor="ctr" wrap="square" lIns="164592" rIns="164592" tIns="182880" bIns="137160"/>
           <a:lstStyle/>
           <a:p>
             <a:pPr algn="ctr">
@@ -6801,7 +6744,7 @@
           </a:fontRef>
         </p:style>
         <p:txBody>
-          <a:bodyPr wrap="square" lIns="164592" tIns="182880" rIns="164592" bIns="137160" rtlCol="0" anchor="ctr"/>
+          <a:bodyPr rtlCol="0" anchor="ctr" wrap="square" lIns="164592" rIns="164592" tIns="182880" bIns="137160"/>
           <a:lstStyle/>
           <a:p>
             <a:pPr algn="ctr">
@@ -6815,7 +6758,7 @@
               </a:defRPr>
             </a:pPr>
             <a:r>
-              <a:t>3. TABLEAU ODBC AUTOMATION</a:t>
+              <a:t>3. POWER BI &amp; TABLEAU</a:t>
             </a:r>
           </a:p>
           <a:p>
@@ -6830,7 +6773,7 @@
               </a:defRPr>
             </a:pPr>
             <a:r>
-              <a:t>• Configured macOS ODBC DSN (`Portfolio_DB`).</a:t>
+              <a:t>• Power BI star schema, DAX measures and theme in `/powerbi/`.</a:t>
             </a:r>
           </a:p>
           <a:p>
@@ -6845,7 +6788,7 @@
               </a:defRPr>
             </a:pPr>
             <a:r>
-              <a:t>• Generated Tableau Data Source (`.tds`) XML for 1-click live connection.</a:t>
+              <a:t>• Three-page dashboard: Overview, Cohort Retention, RFM Segments.</a:t>
             </a:r>
           </a:p>
           <a:p>
@@ -6860,7 +6803,7 @@
               </a:defRPr>
             </a:pPr>
             <a:r>
-              <a:t>• Instantly launched Tableau Desktop for visual exploration.</a:t>
+              <a:t>• Tableau data source (`.tds`) for a live SQLite connection via ODBC.</a:t>
             </a:r>
           </a:p>
         </p:txBody>
@@ -6903,7 +6846,7 @@
           </a:fontRef>
         </p:style>
         <p:txBody>
-          <a:bodyPr wrap="square" lIns="164592" tIns="182880" rIns="164592" bIns="137160" rtlCol="0" anchor="ctr"/>
+          <a:bodyPr rtlCol="0" anchor="ctr" wrap="square" lIns="164592" rIns="164592" tIns="182880" bIns="137160"/>
           <a:lstStyle/>
           <a:p>
             <a:pPr algn="ctr">
@@ -6947,7 +6890,7 @@
               </a:defRPr>
             </a:pPr>
             <a:r>
-              <a:t>• Comprehensive Case Study &amp; KPI Scorecard in `README.md`.</a:t>
+              <a:t>• All figures computed in `src/report_metrics.py`.</a:t>
             </a:r>
           </a:p>
           <a:p>

</xml_diff>